<commit_message>
Teaching the Modules: Modules 3 to 5 slides and pages; QR helper; layout fixes
Co-Authored-By: Claude Opus 5.5 <noreply@anthropic.com>
Claude-Session: https://claude.ai/code/session_01ScysB3hpFWQZ6JoQjpf1xs
</commit_message>
<xml_diff>
--- a/downloads/slides/FYE100-Module01-Instructor-Slides.pptx
+++ b/downloads/slides/FYE100-Module01-Instructor-Slides.pptx
@@ -120,18 +120,18 @@
   <p:extLst>
     <p:ext uri="{521415D9-36F7-43E2-AB2F-B90AF26B5E84}">
       <p14:sectionLst xmlns:p14="http://schemas.microsoft.com/office/powerpoint/2010/main">
-        <p14:section name="Opening" id="{b4b074dd-aa22-bd42-951c-f41cd34bea3a}">
+        <p14:section name="Opening" id="{77216712-6f2c-ed90-4efd-a9cbfedbf16c}">
           <p14:sldIdLst>
             <p14:sldId id="256"/>
             <p14:sldId id="257"/>
           </p14:sldIdLst>
         </p14:section>
-        <p14:section name="This week" id="{b32d08c3-6fbd-d632-8535-1b7e66ce454d}">
+        <p14:section name="This week" id="{5bd05758-b145-2ef7-cfd9-01d0277b2153}">
           <p14:sldIdLst>
             <p14:sldId id="258"/>
           </p14:sldIdLst>
         </p14:section>
-        <p14:section name="Lessons" id="{35e739ff-4e94-2aea-f530-9c4f9262134a}">
+        <p14:section name="Lessons" id="{50ecca83-88a7-aa7a-d569-d5e538a1fb83}">
           <p14:sldIdLst>
             <p14:sldId id="259"/>
             <p14:sldId id="260"/>
@@ -143,13 +143,13 @@
             <p14:sldId id="266"/>
           </p14:sldIdLst>
         </p14:section>
-        <p14:section name="This week's work" id="{1b041d78-f832-e5ba-8e40-8f614290058d}">
+        <p14:section name="This week's work" id="{4b935ef9-a9ad-92f6-eebf-f7cb84457e3f}">
           <p14:sldIdLst>
             <p14:sldId id="267"/>
             <p14:sldId id="268"/>
           </p14:sldIdLst>
         </p14:section>
-        <p14:section name="Discussion" id="{73d819ff-e052-e452-fa8e-56e24b4ad8b7}">
+        <p14:section name="Discussion" id="{6faf32e9-cd31-222d-040e-1df3ba5a25f0}">
           <p14:sldIdLst>
             <p14:sldId id="269"/>
           </p14:sldIdLst>
@@ -2213,7 +2213,7 @@
           <a:lstStyle>
             <a:lvl1pPr algn="l" indent="0" marL="0">
               <a:buNone/>
-              <a:defRPr lang="en-US" sz="4400" b="1" dirty="0">
+              <a:defRPr lang="en-US" sz="4000" b="1" dirty="0">
                 <a:solidFill>
                   <a:schemeClr val="bg1"/>
                 </a:solidFill>
@@ -2224,7 +2224,7 @@
             <a:pPr algn="l" indent="0" marL="0">
               <a:buNone/>
             </a:pPr>
-            <a:endParaRPr lang="en-US" sz="4400" dirty="0"/>
+            <a:endParaRPr lang="en-US" sz="4000" dirty="0"/>
           </a:p>
         </p:txBody>
       </p:sp>
@@ -6044,14 +6044,14 @@
               <a:buNone/>
             </a:pPr>
             <a:r>
-              <a:rPr lang="en-US" sz="4400" b="1" dirty="0">
+              <a:rPr lang="en-US" sz="4000" b="1" dirty="0">
                 <a:solidFill>
                   <a:schemeClr val="bg1"/>
                 </a:solidFill>
               </a:rPr>
               <a:t>Who's on the trail with you?</a:t>
             </a:r>
-            <a:endParaRPr lang="en-US" sz="4400" dirty="0"/>
+            <a:endParaRPr lang="en-US" sz="4000" dirty="0"/>
           </a:p>
         </p:txBody>
       </p:sp>
@@ -6064,7 +6064,7 @@
         <p:spPr>
           <a:xfrm>
             <a:off x="3931920" y="2697480"/>
-            <a:ext cx="7589520" cy="1737360"/>
+            <a:ext cx="7589520" cy="1828800"/>
           </a:xfrm>
           <a:prstGeom prst="rect">
             <a:avLst/>
@@ -6085,14 +6085,14 @@
               <a:buAutoNum type="arabicPeriod" startAt="1"/>
             </a:pPr>
             <a:r>
-              <a:rPr lang="en-US" sz="2600" dirty="0">
+              <a:rPr lang="en-US" sz="2400" dirty="0">
                 <a:solidFill>
                   <a:schemeClr val="bg1"/>
                 </a:solidFill>
               </a:rPr>
               <a:t>Your name, and what you're here for: a program, a goal, or a fresh start.</a:t>
             </a:r>
-            <a:endParaRPr lang="en-US" sz="2600" dirty="0"/>
+            <a:endParaRPr lang="en-US" sz="2400" dirty="0"/>
           </a:p>
           <a:p>
             <a:pPr marL="342900" indent="-342900">
@@ -6104,14 +6104,14 @@
               <a:buAutoNum type="arabicPeriod" startAt="1"/>
             </a:pPr>
             <a:r>
-              <a:rPr lang="en-US" sz="2600" dirty="0">
+              <a:rPr lang="en-US" sz="2400" dirty="0">
                 <a:solidFill>
                   <a:schemeClr val="bg1"/>
                 </a:solidFill>
               </a:rPr>
               <a:t>One thing you're bringing with you: a skill, a habit, or a story.</a:t>
             </a:r>
-            <a:endParaRPr lang="en-US" sz="2600" dirty="0"/>
+            <a:endParaRPr lang="en-US" sz="2400" dirty="0"/>
           </a:p>
         </p:txBody>
       </p:sp>
@@ -6123,7 +6123,7 @@
         </p:nvSpPr>
         <p:spPr>
           <a:xfrm>
-            <a:off x="3931920" y="4526280"/>
+            <a:off x="3931920" y="4617720"/>
             <a:ext cx="5120640" cy="731520"/>
           </a:xfrm>
           <a:prstGeom prst="rect">

</xml_diff>

<commit_message>
Module 1 slides: QR code for the Spring 2027 Skills Snapshot form
Co-Authored-By: Claude Opus 5.5 <noreply@anthropic.com>
Claude-Session: https://claude.ai/code/session_01ScysB3hpFWQZ6JoQjpf1xs
</commit_message>
<xml_diff>
--- a/downloads/slides/FYE100-Module01-Instructor-Slides.pptx
+++ b/downloads/slides/FYE100-Module01-Instructor-Slides.pptx
@@ -120,18 +120,18 @@
   <p:extLst>
     <p:ext uri="{521415D9-36F7-43E2-AB2F-B90AF26B5E84}">
       <p14:sectionLst xmlns:p14="http://schemas.microsoft.com/office/powerpoint/2010/main">
-        <p14:section name="Opening" id="{77216712-6f2c-ed90-4efd-a9cbfedbf16c}">
+        <p14:section name="Opening" id="{8bf445d0-8e6e-88a7-8a00-153fde5dfb92}">
           <p14:sldIdLst>
             <p14:sldId id="256"/>
             <p14:sldId id="257"/>
           </p14:sldIdLst>
         </p14:section>
-        <p14:section name="This week" id="{5bd05758-b145-2ef7-cfd9-01d0277b2153}">
+        <p14:section name="This week" id="{bebd7c36-a1aa-6507-adf8-375ba8b74238}">
           <p14:sldIdLst>
             <p14:sldId id="258"/>
           </p14:sldIdLst>
         </p14:section>
-        <p14:section name="Lessons" id="{50ecca83-88a7-aa7a-d569-d5e538a1fb83}">
+        <p14:section name="Lessons" id="{44a2430d-4759-70fb-a2c8-6fc3f6dbc0fe}">
           <p14:sldIdLst>
             <p14:sldId id="259"/>
             <p14:sldId id="260"/>
@@ -143,13 +143,13 @@
             <p14:sldId id="266"/>
           </p14:sldIdLst>
         </p14:section>
-        <p14:section name="This week's work" id="{4b935ef9-a9ad-92f6-eebf-f7cb84457e3f}">
+        <p14:section name="This week's work" id="{4fe63368-7c71-7f26-8882-52f4aed0187d}">
           <p14:sldIdLst>
             <p14:sldId id="267"/>
             <p14:sldId id="268"/>
           </p14:sldIdLst>
         </p14:section>
-        <p14:section name="Discussion" id="{6faf32e9-cd31-222d-040e-1df3ba5a25f0}">
+        <p14:section name="Discussion" id="{a9ab3219-f6c9-780c-b727-dfca77946b84}">
           <p14:sldIdLst>
             <p14:sldId id="269"/>
           </p14:sldIdLst>
@@ -833,7 +833,8 @@
             <a:r>
               <a:rPr lang="en-US" dirty="0"/>
               <a:t>Everything is due Monday by 11:59 PM Central.
-The My Skills Snapshot is your starting point on the 10 skills and on AI. It's completion only, so be honest, not generous. You'll retake it at the end and compare.
+The My Skills Snapshot is your starting point on the 10 skills and on AI. Scan the code on this slide to open it. It's completion only, so be honest, not generous. You'll retake it at the end and compare.
+INSTRUCTOR NOTE: the QR code is the Spring 2027 Snapshot form. It changes each semester; replace it if your section uses a different form.
 The BE Check is a short matching quiz on the five BE behaviors from Lesson 1.3.
 Mile Marker #1 is the main assignment, next slide.
 Online sections also have the Trailhead Introductions discussion: first post by Friday, replies by Monday. In-person sections: today's attendance counts.
@@ -4467,7 +4468,7 @@
       </p:sp>
       <p:sp>
         <p:nvSpPr>
-          <p:cNvPr id="4" name="Decorative: assignment row">
+          <p:cNvPr id="4" name="Decorative: QR panel">
             <a:extLst>
               <a:ext uri="{C183D7F6-B498-43B3-948B-1728B52AA6E4}">
                 <adec:decorative xmlns:adec="http://schemas.microsoft.com/office/drawing/2017/decorative" val="1"/>
@@ -4479,8 +4480,177 @@
         </p:nvSpPr>
         <p:spPr>
           <a:xfrm>
+            <a:off x="8534095" y="1874520"/>
+            <a:ext cx="3108960" cy="3977640"/>
+          </a:xfrm>
+          <a:prstGeom prst="roundRect">
+            <a:avLst>
+              <a:gd name="adj" fmla="val 3529"/>
+            </a:avLst>
+          </a:prstGeom>
+          <a:solidFill>
+            <a:srgbClr val="FFF5DC"/>
+          </a:solidFill>
+          <a:ln w="12700">
+            <a:solidFill>
+              <a:srgbClr val="FFF5DC"/>
+            </a:solidFill>
+            <a:prstDash val="solid"/>
+          </a:ln>
+          <a:effectLst>
+            <a:outerShdw sx="100000" sy="100000" kx="0" ky="0" algn="bl" rotWithShape="0" blurRad="101600" dist="25400" dir="5400000">
+              <a:srgbClr val="000000">
+                <a:alpha val="12000"/>
+              </a:srgbClr>
+            </a:outerShdw>
+          </a:effectLst>
+        </p:spPr>
+      </p:sp>
+      <p:sp>
+        <p:nvSpPr>
+          <p:cNvPr id="5" name="Text 3"/>
+          <p:cNvSpPr txBox="1"/>
+          <p:nvPr/>
+        </p:nvSpPr>
+        <p:spPr>
+          <a:xfrm>
+            <a:off x="8762695" y="2011680"/>
+            <a:ext cx="2651760" cy="685800"/>
+          </a:xfrm>
+          <a:prstGeom prst="rect">
+            <a:avLst/>
+          </a:prstGeom>
+          <a:noFill/>
+          <a:ln/>
+        </p:spPr>
+        <p:txBody>
+          <a:bodyPr wrap="square" lIns="0" tIns="0" rIns="0" bIns="0" rtlCol="0" anchor="ctr"/>
+          <a:lstStyle/>
+          <a:p>
+            <a:pPr algn="ctr" indent="0" marL="0">
+              <a:buNone/>
+            </a:pPr>
+            <a:r>
+              <a:rPr lang="en-US" sz="2000" b="1" dirty="0">
+                <a:solidFill>
+                  <a:schemeClr val="tx2"/>
+                </a:solidFill>
+              </a:rPr>
+              <a:t>Scan for My Skills Snapshot</a:t>
+            </a:r>
+            <a:endParaRPr lang="en-US" sz="2000" dirty="0"/>
+          </a:p>
+        </p:txBody>
+      </p:sp>
+      <p:sp>
+        <p:nvSpPr>
+          <p:cNvPr id="6" name="Decorative: QR frame">
+            <a:extLst>
+              <a:ext uri="{C183D7F6-B498-43B3-948B-1728B52AA6E4}">
+                <adec:decorative xmlns:adec="http://schemas.microsoft.com/office/drawing/2017/decorative" val="1"/>
+              </a:ext>
+            </a:extLst>
+          </p:cNvPr>
+          <p:cNvSpPr/>
+          <p:nvPr/>
+        </p:nvSpPr>
+        <p:spPr>
+          <a:xfrm>
+            <a:off x="8973007" y="2679192"/>
+            <a:ext cx="2231136" cy="2231136"/>
+          </a:xfrm>
+          <a:prstGeom prst="roundRect">
+            <a:avLst>
+              <a:gd name="adj" fmla="val 4098"/>
+            </a:avLst>
+          </a:prstGeom>
+          <a:solidFill>
+            <a:srgbClr val="FFFFFF"/>
+          </a:solidFill>
+          <a:ln w="12700">
+            <a:solidFill>
+              <a:srgbClr val="D9E2EA"/>
+            </a:solidFill>
+            <a:prstDash val="solid"/>
+          </a:ln>
+        </p:spPr>
+      </p:sp>
+      <p:pic>
+        <p:nvPicPr>
+          <p:cNvPr id="7" name="QR code: Scan for My Skills Snapshot" descr="QR code for Scan for My Skills Snapshot: https://forms.cloud.microsoft/r/q1qNGUcQEH?origin=QRCode">    </p:cNvPr>
+          <p:cNvPicPr>
+            <a:picLocks noChangeAspect="1"/>
+          </p:cNvPicPr>
+          <p:nvPr/>
+        </p:nvPicPr>
+        <p:blipFill>
+          <a:blip r:embed="rId1"/>
+          <a:stretch>
+            <a:fillRect/>
+          </a:stretch>
+        </p:blipFill>
+        <p:spPr>
+          <a:xfrm>
+            <a:off x="9082735" y="2788920"/>
+            <a:ext cx="2011680" cy="2011680"/>
+          </a:xfrm>
+          <a:prstGeom prst="rect">
+            <a:avLst/>
+          </a:prstGeom>
+        </p:spPr>
+      </p:pic>
+      <p:sp>
+        <p:nvSpPr>
+          <p:cNvPr id="8" name="Address: Scan for My Skills Snapshot"/>
+          <p:cNvSpPr txBox="1"/>
+          <p:nvPr/>
+        </p:nvSpPr>
+        <p:spPr>
+          <a:xfrm>
+            <a:off x="8534095" y="4937760"/>
+            <a:ext cx="3108960" cy="731520"/>
+          </a:xfrm>
+          <a:prstGeom prst="rect">
+            <a:avLst/>
+          </a:prstGeom>
+          <a:noFill/>
+          <a:ln/>
+        </p:spPr>
+        <p:txBody>
+          <a:bodyPr wrap="square" lIns="0" tIns="0" rIns="0" bIns="0" rtlCol="0" anchor="t"/>
+          <a:lstStyle/>
+          <a:p>
+            <a:pPr algn="ctr" indent="0" marL="0">
+              <a:buNone/>
+            </a:pPr>
+            <a:r>
+              <a:rPr lang="en-US" sz="2000" dirty="0">
+                <a:solidFill>
+                  <a:schemeClr val="accent6"/>
+                </a:solidFill>
+              </a:rPr>
+              <a:t>forms.cloud.microsoft/r/q1qNGUcQEH</a:t>
+            </a:r>
+            <a:endParaRPr lang="en-US" sz="2000" dirty="0"/>
+          </a:p>
+        </p:txBody>
+      </p:sp>
+      <p:sp>
+        <p:nvSpPr>
+          <p:cNvPr id="9" name="Decorative: assignment row">
+            <a:extLst>
+              <a:ext uri="{C183D7F6-B498-43B3-948B-1728B52AA6E4}">
+                <adec:decorative xmlns:adec="http://schemas.microsoft.com/office/drawing/2017/decorative" val="1"/>
+              </a:ext>
+            </a:extLst>
+          </p:cNvPr>
+          <p:cNvSpPr/>
+          <p:nvPr/>
+        </p:nvSpPr>
+        <p:spPr>
+          <a:xfrm>
             <a:off x="548640" y="1874520"/>
-            <a:ext cx="11094415" cy="841248"/>
+            <a:ext cx="7665415" cy="841248"/>
           </a:xfrm>
           <a:prstGeom prst="roundRect">
             <a:avLst>
@@ -4507,7 +4677,7 @@
       </p:sp>
       <p:sp>
         <p:nvSpPr>
-          <p:cNvPr id="5" name="Decorative: icon circle">
+          <p:cNvPr id="10" name="Decorative: icon circle">
             <a:extLst>
               <a:ext uri="{C183D7F6-B498-43B3-948B-1728B52AA6E4}">
                 <adec:decorative xmlns:adec="http://schemas.microsoft.com/office/drawing/2017/decorative" val="1"/>
@@ -4538,7 +4708,7 @@
       </p:sp>
       <p:pic>
         <p:nvPicPr>
-          <p:cNvPr id="6" name="Decorative: LuClipboardCheck">
+          <p:cNvPr id="11" name="Decorative: LuClipboardCheck">
             <a:extLst>
               <a:ext uri="{C183D7F6-B498-43B3-948B-1728B52AA6E4}">
                 <adec:decorative xmlns:adec="http://schemas.microsoft.com/office/drawing/2017/decorative" val="1"/>
@@ -4551,7 +4721,7 @@
           <p:nvPr/>
         </p:nvPicPr>
         <p:blipFill>
-          <a:blip r:embed="rId1"/>
+          <a:blip r:embed="rId2"/>
           <a:stretch>
             <a:fillRect/>
           </a:stretch>
@@ -4568,14 +4738,14 @@
       </p:pic>
       <p:sp>
         <p:nvSpPr>
-          <p:cNvPr id="7" name="Text 4"/>
+          <p:cNvPr id="12" name="Text 8"/>
           <p:cNvSpPr txBox="1"/>
           <p:nvPr/>
         </p:nvSpPr>
         <p:spPr>
           <a:xfrm>
             <a:off x="1508760" y="1929384"/>
-            <a:ext cx="9814255" cy="731520"/>
+            <a:ext cx="6385255" cy="731520"/>
           </a:xfrm>
           <a:prstGeom prst="rect">
             <a:avLst/>
@@ -4618,7 +4788,7 @@
       </p:sp>
       <p:sp>
         <p:nvSpPr>
-          <p:cNvPr id="8" name="Decorative: assignment row">
+          <p:cNvPr id="13" name="Decorative: assignment row">
             <a:extLst>
               <a:ext uri="{C183D7F6-B498-43B3-948B-1728B52AA6E4}">
                 <adec:decorative xmlns:adec="http://schemas.microsoft.com/office/drawing/2017/decorative" val="1"/>
@@ -4631,7 +4801,7 @@
         <p:spPr>
           <a:xfrm>
             <a:off x="548640" y="2880360"/>
-            <a:ext cx="11094415" cy="841248"/>
+            <a:ext cx="7665415" cy="841248"/>
           </a:xfrm>
           <a:prstGeom prst="roundRect">
             <a:avLst>
@@ -4658,7 +4828,7 @@
       </p:sp>
       <p:sp>
         <p:nvSpPr>
-          <p:cNvPr id="9" name="Decorative: icon circle">
+          <p:cNvPr id="14" name="Decorative: icon circle">
             <a:extLst>
               <a:ext uri="{C183D7F6-B498-43B3-948B-1728B52AA6E4}">
                 <adec:decorative xmlns:adec="http://schemas.microsoft.com/office/drawing/2017/decorative" val="1"/>
@@ -4689,7 +4859,7 @@
       </p:sp>
       <p:pic>
         <p:nvPicPr>
-          <p:cNvPr id="10" name="Decorative: LuCircleCheck">
+          <p:cNvPr id="15" name="Decorative: LuCircleCheck">
             <a:extLst>
               <a:ext uri="{C183D7F6-B498-43B3-948B-1728B52AA6E4}">
                 <adec:decorative xmlns:adec="http://schemas.microsoft.com/office/drawing/2017/decorative" val="1"/>
@@ -4702,7 +4872,7 @@
           <p:nvPr/>
         </p:nvPicPr>
         <p:blipFill>
-          <a:blip r:embed="rId2"/>
+          <a:blip r:embed="rId3"/>
           <a:stretch>
             <a:fillRect/>
           </a:stretch>
@@ -4719,14 +4889,14 @@
       </p:pic>
       <p:sp>
         <p:nvSpPr>
-          <p:cNvPr id="11" name="Text 7"/>
+          <p:cNvPr id="16" name="Text 11"/>
           <p:cNvSpPr txBox="1"/>
           <p:nvPr/>
         </p:nvSpPr>
         <p:spPr>
           <a:xfrm>
             <a:off x="1508760" y="2935224"/>
-            <a:ext cx="9814255" cy="731520"/>
+            <a:ext cx="6385255" cy="731520"/>
           </a:xfrm>
           <a:prstGeom prst="rect">
             <a:avLst/>
@@ -4769,7 +4939,7 @@
       </p:sp>
       <p:sp>
         <p:nvSpPr>
-          <p:cNvPr id="12" name="Decorative: assignment row">
+          <p:cNvPr id="17" name="Decorative: assignment row">
             <a:extLst>
               <a:ext uri="{C183D7F6-B498-43B3-948B-1728B52AA6E4}">
                 <adec:decorative xmlns:adec="http://schemas.microsoft.com/office/drawing/2017/decorative" val="1"/>
@@ -4782,7 +4952,7 @@
         <p:spPr>
           <a:xfrm>
             <a:off x="548640" y="3886200"/>
-            <a:ext cx="11094415" cy="841248"/>
+            <a:ext cx="7665415" cy="841248"/>
           </a:xfrm>
           <a:prstGeom prst="roundRect">
             <a:avLst>
@@ -4809,7 +4979,7 @@
       </p:sp>
       <p:sp>
         <p:nvSpPr>
-          <p:cNvPr id="13" name="Decorative: icon circle">
+          <p:cNvPr id="18" name="Decorative: icon circle">
             <a:extLst>
               <a:ext uri="{C183D7F6-B498-43B3-948B-1728B52AA6E4}">
                 <adec:decorative xmlns:adec="http://schemas.microsoft.com/office/drawing/2017/decorative" val="1"/>
@@ -4840,7 +5010,7 @@
       </p:sp>
       <p:pic>
         <p:nvPicPr>
-          <p:cNvPr id="14" name="Decorative: LuFlag">
+          <p:cNvPr id="19" name="Decorative: LuFlag">
             <a:extLst>
               <a:ext uri="{C183D7F6-B498-43B3-948B-1728B52AA6E4}">
                 <adec:decorative xmlns:adec="http://schemas.microsoft.com/office/drawing/2017/decorative" val="1"/>
@@ -4853,7 +5023,7 @@
           <p:nvPr/>
         </p:nvPicPr>
         <p:blipFill>
-          <a:blip r:embed="rId3"/>
+          <a:blip r:embed="rId4"/>
           <a:stretch>
             <a:fillRect/>
           </a:stretch>
@@ -4870,14 +5040,14 @@
       </p:pic>
       <p:sp>
         <p:nvSpPr>
-          <p:cNvPr id="15" name="Text 10"/>
+          <p:cNvPr id="20" name="Text 14"/>
           <p:cNvSpPr txBox="1"/>
           <p:nvPr/>
         </p:nvSpPr>
         <p:spPr>
           <a:xfrm>
             <a:off x="1508760" y="3941064"/>
-            <a:ext cx="9814255" cy="731520"/>
+            <a:ext cx="6385255" cy="731520"/>
           </a:xfrm>
           <a:prstGeom prst="rect">
             <a:avLst/>
@@ -4920,7 +5090,7 @@
       </p:sp>
       <p:sp>
         <p:nvSpPr>
-          <p:cNvPr id="16" name="Decorative: assignment row">
+          <p:cNvPr id="21" name="Decorative: assignment row">
             <a:extLst>
               <a:ext uri="{C183D7F6-B498-43B3-948B-1728B52AA6E4}">
                 <adec:decorative xmlns:adec="http://schemas.microsoft.com/office/drawing/2017/decorative" val="1"/>
@@ -4933,7 +5103,7 @@
         <p:spPr>
           <a:xfrm>
             <a:off x="548640" y="4892040"/>
-            <a:ext cx="11094415" cy="841248"/>
+            <a:ext cx="7665415" cy="841248"/>
           </a:xfrm>
           <a:prstGeom prst="roundRect">
             <a:avLst>
@@ -4960,7 +5130,7 @@
       </p:sp>
       <p:sp>
         <p:nvSpPr>
-          <p:cNvPr id="17" name="Decorative: icon circle">
+          <p:cNvPr id="22" name="Decorative: icon circle">
             <a:extLst>
               <a:ext uri="{C183D7F6-B498-43B3-948B-1728B52AA6E4}">
                 <adec:decorative xmlns:adec="http://schemas.microsoft.com/office/drawing/2017/decorative" val="1"/>
@@ -4991,7 +5161,7 @@
       </p:sp>
       <p:pic>
         <p:nvPicPr>
-          <p:cNvPr id="18" name="Decorative: LuMessagesSquare">
+          <p:cNvPr id="23" name="Decorative: LuMessagesSquare">
             <a:extLst>
               <a:ext uri="{C183D7F6-B498-43B3-948B-1728B52AA6E4}">
                 <adec:decorative xmlns:adec="http://schemas.microsoft.com/office/drawing/2017/decorative" val="1"/>
@@ -5004,7 +5174,7 @@
           <p:nvPr/>
         </p:nvPicPr>
         <p:blipFill>
-          <a:blip r:embed="rId4"/>
+          <a:blip r:embed="rId5"/>
           <a:stretch>
             <a:fillRect/>
           </a:stretch>
@@ -5021,14 +5191,14 @@
       </p:pic>
       <p:sp>
         <p:nvSpPr>
-          <p:cNvPr id="19" name="Text 13"/>
+          <p:cNvPr id="24" name="Text 17"/>
           <p:cNvSpPr txBox="1"/>
           <p:nvPr/>
         </p:nvSpPr>
         <p:spPr>
           <a:xfrm>
             <a:off x="1508760" y="4946904"/>
-            <a:ext cx="9814255" cy="731520"/>
+            <a:ext cx="6385255" cy="731520"/>
           </a:xfrm>
           <a:prstGeom prst="rect">
             <a:avLst/>

</xml_diff>

<commit_message>
Slides: semester links in term.json (Spring 2027, 4266); Skills Snapshot start and end forms
Co-Authored-By: Claude Opus 5.5 <noreply@anthropic.com>
Claude-Session: https://claude.ai/code/session_01ScysB3hpFWQZ6JoQjpf1xs
</commit_message>
<xml_diff>
--- a/downloads/slides/FYE100-Module01-Instructor-Slides.pptx
+++ b/downloads/slides/FYE100-Module01-Instructor-Slides.pptx
@@ -120,18 +120,18 @@
   <p:extLst>
     <p:ext uri="{521415D9-36F7-43E2-AB2F-B90AF26B5E84}">
       <p14:sectionLst xmlns:p14="http://schemas.microsoft.com/office/powerpoint/2010/main">
-        <p14:section name="Opening" id="{8bf445d0-8e6e-88a7-8a00-153fde5dfb92}">
+        <p14:section name="Opening" id="{7cae0c6c-1090-589e-5745-8fc18a1b6b2f}">
           <p14:sldIdLst>
             <p14:sldId id="256"/>
             <p14:sldId id="257"/>
           </p14:sldIdLst>
         </p14:section>
-        <p14:section name="This week" id="{bebd7c36-a1aa-6507-adf8-375ba8b74238}">
+        <p14:section name="This week" id="{0d2634a2-7d18-6930-dce9-a09fe361439c}">
           <p14:sldIdLst>
             <p14:sldId id="258"/>
           </p14:sldIdLst>
         </p14:section>
-        <p14:section name="Lessons" id="{44a2430d-4759-70fb-a2c8-6fc3f6dbc0fe}">
+        <p14:section name="Lessons" id="{d1544e57-bf8e-01bb-72d2-ba4ba8d63019}">
           <p14:sldIdLst>
             <p14:sldId id="259"/>
             <p14:sldId id="260"/>
@@ -143,13 +143,13 @@
             <p14:sldId id="266"/>
           </p14:sldIdLst>
         </p14:section>
-        <p14:section name="This week's work" id="{4fe63368-7c71-7f26-8882-52f4aed0187d}">
+        <p14:section name="This week's work" id="{c4f7275b-ebee-df91-4ee3-9f31696d60cd}">
           <p14:sldIdLst>
             <p14:sldId id="267"/>
             <p14:sldId id="268"/>
           </p14:sldIdLst>
         </p14:section>
-        <p14:section name="Discussion" id="{a9ab3219-f6c9-780c-b727-dfca77946b84}">
+        <p14:section name="Discussion" id="{265e8d13-b043-b8b7-50f3-20a81f9c6896}">
           <p14:sldIdLst>
             <p14:sldId id="269"/>
           </p14:sldIdLst>
@@ -834,7 +834,7 @@
               <a:rPr lang="en-US" dirty="0"/>
               <a:t>Everything is due Monday by 11:59 PM Central.
 The My Skills Snapshot is your starting point on the 10 skills and on AI. Scan the code on this slide to open it. It's completion only, so be honest, not generous. You'll retake it at the end and compare.
-INSTRUCTOR NOTE: the QR code is the Spring 2027 Snapshot form. It changes each semester; replace it if your section uses a different form.
+INSTRUCTOR NOTE: the QR code opens this semester's shared Snapshot form for all FYE 100 sections. It changes each semester.
 The BE Check is a short matching quiz on the five BE behaviors from Lesson 1.3.
 Mile Marker #1 is the main assignment, next slide.
 Online sections also have the Trailhead Introductions discussion: first post by Friday, replies by Monday. In-person sections: today's attendance counts.

</xml_diff>

<commit_message>
Capstone overview deck: STAR(T) Stories, with the storytelling owl; linked from Teaching the Modules
Co-Authored-By: Claude Opus 5.5 <noreply@anthropic.com>
Claude-Session: https://claude.ai/code/session_01ScysB3hpFWQZ6JoQjpf1xs
</commit_message>
<xml_diff>
--- a/downloads/slides/FYE100-Module01-Instructor-Slides.pptx
+++ b/downloads/slides/FYE100-Module01-Instructor-Slides.pptx
@@ -120,18 +120,18 @@
   <p:extLst>
     <p:ext uri="{521415D9-36F7-43E2-AB2F-B90AF26B5E84}">
       <p14:sectionLst xmlns:p14="http://schemas.microsoft.com/office/powerpoint/2010/main">
-        <p14:section name="Opening" id="{7cae0c6c-1090-589e-5745-8fc18a1b6b2f}">
+        <p14:section name="Opening" id="{f3eaaf80-78f9-4814-5d5d-5060da19d199}">
           <p14:sldIdLst>
             <p14:sldId id="256"/>
             <p14:sldId id="257"/>
           </p14:sldIdLst>
         </p14:section>
-        <p14:section name="This week" id="{0d2634a2-7d18-6930-dce9-a09fe361439c}">
+        <p14:section name="This week" id="{81d14429-8b8f-6a5f-b084-fdad7aef1e9d}">
           <p14:sldIdLst>
             <p14:sldId id="258"/>
           </p14:sldIdLst>
         </p14:section>
-        <p14:section name="Lessons" id="{d1544e57-bf8e-01bb-72d2-ba4ba8d63019}">
+        <p14:section name="Lessons" id="{10100579-f500-6b6e-7bfb-9d9d14b2b5f1}">
           <p14:sldIdLst>
             <p14:sldId id="259"/>
             <p14:sldId id="260"/>
@@ -143,13 +143,13 @@
             <p14:sldId id="266"/>
           </p14:sldIdLst>
         </p14:section>
-        <p14:section name="This week's work" id="{c4f7275b-ebee-df91-4ee3-9f31696d60cd}">
+        <p14:section name="This week's work" id="{35435d67-0425-754d-f2d4-a07edb84ea97}">
           <p14:sldIdLst>
             <p14:sldId id="267"/>
             <p14:sldId id="268"/>
           </p14:sldIdLst>
         </p14:section>
-        <p14:section name="Discussion" id="{265e8d13-b043-b8b7-50f3-20a81f9c6896}">
+        <p14:section name="Discussion" id="{568174e8-c83e-ddb3-9e86-74056ccda977}">
           <p14:sldIdLst>
             <p14:sldId id="269"/>
           </p14:sldIdLst>

</xml_diff>